<commit_message>
data analysis lect tweak
</commit_message>
<xml_diff>
--- a/static/courses/cis-7000-spring2026/downloads/SSEM-data-analysis-2.pptx
+++ b/static/courses/cis-7000-spring2026/downloads/SSEM-data-analysis-2.pptx
@@ -14218,7 +14218,15 @@
             <a:pPr lvl="0"/>
             <a:r>
               <a:rPr dirty="0"/>
-              <a:t>Model explains 81% of variance in CVSS</a:t>
+              <a:t>Model explains </a:t>
+            </a:r>
+            <a:r>
+              <a:rPr lang="en-US" dirty="0"/>
+              <a:t>59</a:t>
+            </a:r>
+            <a:r>
+              <a:rPr dirty="0"/>
+              <a:t>% of variance in CVSS</a:t>
             </a:r>
           </a:p>
         </p:txBody>

</xml_diff>